<commit_message>
support multi rate calculation
</commit_message>
<xml_diff>
--- a/fig.pptx
+++ b/fig.pptx
@@ -5,10 +5,12 @@
     <p:sldMasterId id="2147483648" r:id="rId1"/>
   </p:sldMasterIdLst>
   <p:notesMasterIdLst>
-    <p:notesMasterId r:id="rId3"/>
+    <p:notesMasterId r:id="rId5"/>
   </p:notesMasterIdLst>
   <p:sldIdLst>
     <p:sldId id="256" r:id="rId2"/>
+    <p:sldId id="257" r:id="rId3"/>
+    <p:sldId id="258" r:id="rId4"/>
   </p:sldIdLst>
   <p:sldSz cx="12192000" cy="6858000"/>
   <p:notesSz cx="6858000" cy="9144000"/>
@@ -107,6 +109,11 @@
       </a:defRPr>
     </a:lvl9pPr>
   </p:defaultTextStyle>
+  <p:extLst>
+    <p:ext uri="{EFAFB233-063F-42B5-8137-9DF3F51BA10A}">
+      <p15:sldGuideLst xmlns:p15="http://schemas.microsoft.com/office/powerpoint/2012/main"/>
+    </p:ext>
+  </p:extLst>
 </p:presentation>
 </file>
 
@@ -192,7 +199,7 @@
           <a:p>
             <a:fld id="{E327D841-92B2-9947-94AA-973D4D517240}" type="datetimeFigureOut">
               <a:rPr lang="en-US" smtClean="0"/>
-              <a:t>5/6/26</a:t>
+              <a:t>7/13/26</a:t>
             </a:fld>
             <a:endParaRPr lang="en-US"/>
           </a:p>
@@ -690,7 +697,7 @@
           <a:p>
             <a:fld id="{ECEB9517-3F80-3145-BDE0-0E7C7A0F8AD2}" type="datetimeFigureOut">
               <a:rPr lang="en-US" smtClean="0"/>
-              <a:t>5/6/26</a:t>
+              <a:t>7/13/26</a:t>
             </a:fld>
             <a:endParaRPr lang="en-US"/>
           </a:p>
@@ -888,7 +895,7 @@
           <a:p>
             <a:fld id="{ECEB9517-3F80-3145-BDE0-0E7C7A0F8AD2}" type="datetimeFigureOut">
               <a:rPr lang="en-US" smtClean="0"/>
-              <a:t>5/6/26</a:t>
+              <a:t>7/13/26</a:t>
             </a:fld>
             <a:endParaRPr lang="en-US"/>
           </a:p>
@@ -1096,7 +1103,7 @@
           <a:p>
             <a:fld id="{ECEB9517-3F80-3145-BDE0-0E7C7A0F8AD2}" type="datetimeFigureOut">
               <a:rPr lang="en-US" smtClean="0"/>
-              <a:t>5/6/26</a:t>
+              <a:t>7/13/26</a:t>
             </a:fld>
             <a:endParaRPr lang="en-US"/>
           </a:p>
@@ -1294,7 +1301,7 @@
           <a:p>
             <a:fld id="{ECEB9517-3F80-3145-BDE0-0E7C7A0F8AD2}" type="datetimeFigureOut">
               <a:rPr lang="en-US" smtClean="0"/>
-              <a:t>5/6/26</a:t>
+              <a:t>7/13/26</a:t>
             </a:fld>
             <a:endParaRPr lang="en-US"/>
           </a:p>
@@ -1569,7 +1576,7 @@
           <a:p>
             <a:fld id="{ECEB9517-3F80-3145-BDE0-0E7C7A0F8AD2}" type="datetimeFigureOut">
               <a:rPr lang="en-US" smtClean="0"/>
-              <a:t>5/6/26</a:t>
+              <a:t>7/13/26</a:t>
             </a:fld>
             <a:endParaRPr lang="en-US"/>
           </a:p>
@@ -1834,7 +1841,7 @@
           <a:p>
             <a:fld id="{ECEB9517-3F80-3145-BDE0-0E7C7A0F8AD2}" type="datetimeFigureOut">
               <a:rPr lang="en-US" smtClean="0"/>
-              <a:t>5/6/26</a:t>
+              <a:t>7/13/26</a:t>
             </a:fld>
             <a:endParaRPr lang="en-US"/>
           </a:p>
@@ -2246,7 +2253,7 @@
           <a:p>
             <a:fld id="{ECEB9517-3F80-3145-BDE0-0E7C7A0F8AD2}" type="datetimeFigureOut">
               <a:rPr lang="en-US" smtClean="0"/>
-              <a:t>5/6/26</a:t>
+              <a:t>7/13/26</a:t>
             </a:fld>
             <a:endParaRPr lang="en-US"/>
           </a:p>
@@ -2387,7 +2394,7 @@
           <a:p>
             <a:fld id="{ECEB9517-3F80-3145-BDE0-0E7C7A0F8AD2}" type="datetimeFigureOut">
               <a:rPr lang="en-US" smtClean="0"/>
-              <a:t>5/6/26</a:t>
+              <a:t>7/13/26</a:t>
             </a:fld>
             <a:endParaRPr lang="en-US"/>
           </a:p>
@@ -2500,7 +2507,7 @@
           <a:p>
             <a:fld id="{ECEB9517-3F80-3145-BDE0-0E7C7A0F8AD2}" type="datetimeFigureOut">
               <a:rPr lang="en-US" smtClean="0"/>
-              <a:t>5/6/26</a:t>
+              <a:t>7/13/26</a:t>
             </a:fld>
             <a:endParaRPr lang="en-US"/>
           </a:p>
@@ -2811,7 +2818,7 @@
           <a:p>
             <a:fld id="{ECEB9517-3F80-3145-BDE0-0E7C7A0F8AD2}" type="datetimeFigureOut">
               <a:rPr lang="en-US" smtClean="0"/>
-              <a:t>5/6/26</a:t>
+              <a:t>7/13/26</a:t>
             </a:fld>
             <a:endParaRPr lang="en-US"/>
           </a:p>
@@ -3099,7 +3106,7 @@
           <a:p>
             <a:fld id="{ECEB9517-3F80-3145-BDE0-0E7C7A0F8AD2}" type="datetimeFigureOut">
               <a:rPr lang="en-US" smtClean="0"/>
-              <a:t>5/6/26</a:t>
+              <a:t>7/13/26</a:t>
             </a:fld>
             <a:endParaRPr lang="en-US"/>
           </a:p>
@@ -3340,7 +3347,7 @@
           <a:p>
             <a:fld id="{ECEB9517-3F80-3145-BDE0-0E7C7A0F8AD2}" type="datetimeFigureOut">
               <a:rPr lang="en-US" smtClean="0"/>
-              <a:t>5/6/26</a:t>
+              <a:t>7/13/26</a:t>
             </a:fld>
             <a:endParaRPr lang="en-US"/>
           </a:p>
@@ -3991,6 +3998,776 @@
     <p:extLst>
       <p:ext uri="{BB962C8B-B14F-4D97-AF65-F5344CB8AC3E}">
         <p14:creationId xmlns:p14="http://schemas.microsoft.com/office/powerpoint/2010/main" val="4011100397"/>
+      </p:ext>
+    </p:extLst>
+  </p:cSld>
+  <p:clrMapOvr>
+    <a:masterClrMapping/>
+  </p:clrMapOvr>
+</p:sld>
+</file>
+
+<file path=ppt/slides/slide2.xml><?xml version="1.0" encoding="utf-8"?>
+<p:sld xmlns:a="http://schemas.openxmlformats.org/drawingml/2006/main" xmlns:r="http://schemas.openxmlformats.org/officeDocument/2006/relationships" xmlns:p="http://schemas.openxmlformats.org/presentationml/2006/main">
+  <p:cSld>
+    <p:spTree>
+      <p:nvGrpSpPr>
+        <p:cNvPr id="1" name=""/>
+        <p:cNvGrpSpPr/>
+        <p:nvPr/>
+      </p:nvGrpSpPr>
+      <p:grpSpPr>
+        <a:xfrm>
+          <a:off x="0" y="0"/>
+          <a:ext cx="0" cy="0"/>
+          <a:chOff x="0" y="0"/>
+          <a:chExt cx="0" cy="0"/>
+        </a:xfrm>
+      </p:grpSpPr>
+      <p:pic>
+        <p:nvPicPr>
+          <p:cNvPr id="4" name="Picture 3">
+            <a:extLst>
+              <a:ext uri="{FF2B5EF4-FFF2-40B4-BE49-F238E27FC236}">
+                <a16:creationId xmlns:a16="http://schemas.microsoft.com/office/drawing/2014/main" id="{8864DF94-2B58-4600-9A1A-996BC6223F30}"/>
+              </a:ext>
+            </a:extLst>
+          </p:cNvPr>
+          <p:cNvPicPr>
+            <a:picLocks noChangeAspect="1"/>
+          </p:cNvPicPr>
+          <p:nvPr/>
+        </p:nvPicPr>
+        <p:blipFill>
+          <a:blip r:embed="rId2"/>
+          <a:stretch>
+            <a:fillRect/>
+          </a:stretch>
+        </p:blipFill>
+        <p:spPr>
+          <a:xfrm>
+            <a:off x="757959" y="1757218"/>
+            <a:ext cx="3340100" cy="2616200"/>
+          </a:xfrm>
+          <a:prstGeom prst="rect">
+            <a:avLst/>
+          </a:prstGeom>
+        </p:spPr>
+      </p:pic>
+      <p:sp>
+        <p:nvSpPr>
+          <p:cNvPr id="5" name="Rounded Rectangle 4">
+            <a:extLst>
+              <a:ext uri="{FF2B5EF4-FFF2-40B4-BE49-F238E27FC236}">
+                <a16:creationId xmlns:a16="http://schemas.microsoft.com/office/drawing/2014/main" id="{C1017475-D92C-7D27-BD69-20BC102453B6}"/>
+              </a:ext>
+            </a:extLst>
+          </p:cNvPr>
+          <p:cNvSpPr/>
+          <p:nvPr/>
+        </p:nvSpPr>
+        <p:spPr>
+          <a:xfrm>
+            <a:off x="4592782" y="1757218"/>
+            <a:ext cx="1735282" cy="322118"/>
+          </a:xfrm>
+          <a:prstGeom prst="roundRect">
+            <a:avLst>
+              <a:gd name="adj" fmla="val 50000"/>
+            </a:avLst>
+          </a:prstGeom>
+          <a:solidFill>
+            <a:schemeClr val="tx1"/>
+          </a:solidFill>
+          <a:ln>
+            <a:noFill/>
+          </a:ln>
+        </p:spPr>
+        <p:style>
+          <a:lnRef idx="2">
+            <a:schemeClr val="accent1">
+              <a:shade val="15000"/>
+            </a:schemeClr>
+          </a:lnRef>
+          <a:fillRef idx="1">
+            <a:schemeClr val="accent1"/>
+          </a:fillRef>
+          <a:effectRef idx="0">
+            <a:schemeClr val="accent1"/>
+          </a:effectRef>
+          <a:fontRef idx="minor">
+            <a:schemeClr val="lt1"/>
+          </a:fontRef>
+        </p:style>
+        <p:txBody>
+          <a:bodyPr rtlCol="0" anchor="ctr"/>
+          <a:lstStyle/>
+          <a:p>
+            <a:pPr algn="ctr"/>
+            <a:r>
+              <a:rPr lang="en-US" sz="1600" dirty="0"/>
+              <a:t>PV technology</a:t>
+            </a:r>
+          </a:p>
+        </p:txBody>
+      </p:sp>
+      <p:sp>
+        <p:nvSpPr>
+          <p:cNvPr id="6" name="Rounded Rectangle 5">
+            <a:extLst>
+              <a:ext uri="{FF2B5EF4-FFF2-40B4-BE49-F238E27FC236}">
+                <a16:creationId xmlns:a16="http://schemas.microsoft.com/office/drawing/2014/main" id="{475513E1-BA86-9517-4750-7CB90DE81851}"/>
+              </a:ext>
+            </a:extLst>
+          </p:cNvPr>
+          <p:cNvSpPr/>
+          <p:nvPr/>
+        </p:nvSpPr>
+        <p:spPr>
+          <a:xfrm>
+            <a:off x="6459682" y="1757218"/>
+            <a:ext cx="1735282" cy="322118"/>
+          </a:xfrm>
+          <a:prstGeom prst="roundRect">
+            <a:avLst>
+              <a:gd name="adj" fmla="val 50000"/>
+            </a:avLst>
+          </a:prstGeom>
+          <a:solidFill>
+            <a:schemeClr val="tx2">
+              <a:lumMod val="10000"/>
+              <a:lumOff val="90000"/>
+            </a:schemeClr>
+          </a:solidFill>
+          <a:ln>
+            <a:noFill/>
+          </a:ln>
+        </p:spPr>
+        <p:style>
+          <a:lnRef idx="2">
+            <a:schemeClr val="accent1">
+              <a:shade val="15000"/>
+            </a:schemeClr>
+          </a:lnRef>
+          <a:fillRef idx="1">
+            <a:schemeClr val="accent1"/>
+          </a:fillRef>
+          <a:effectRef idx="0">
+            <a:schemeClr val="accent1"/>
+          </a:effectRef>
+          <a:fontRef idx="minor">
+            <a:schemeClr val="lt1"/>
+          </a:fontRef>
+        </p:style>
+        <p:txBody>
+          <a:bodyPr rtlCol="0" anchor="ctr"/>
+          <a:lstStyle/>
+          <a:p>
+            <a:pPr algn="ctr"/>
+            <a:r>
+              <a:rPr lang="en-US" sz="1600" dirty="0">
+                <a:solidFill>
+                  <a:schemeClr val="bg1"/>
+                </a:solidFill>
+              </a:rPr>
+              <a:t>Study duration</a:t>
+            </a:r>
+          </a:p>
+        </p:txBody>
+      </p:sp>
+      <p:sp>
+        <p:nvSpPr>
+          <p:cNvPr id="7" name="Rounded Rectangle 6">
+            <a:extLst>
+              <a:ext uri="{FF2B5EF4-FFF2-40B4-BE49-F238E27FC236}">
+                <a16:creationId xmlns:a16="http://schemas.microsoft.com/office/drawing/2014/main" id="{B64C66A4-D02A-4D91-EC3A-D676ED0EB237}"/>
+              </a:ext>
+            </a:extLst>
+          </p:cNvPr>
+          <p:cNvSpPr/>
+          <p:nvPr/>
+        </p:nvSpPr>
+        <p:spPr>
+          <a:xfrm>
+            <a:off x="8326582" y="1757218"/>
+            <a:ext cx="983673" cy="322118"/>
+          </a:xfrm>
+          <a:prstGeom prst="roundRect">
+            <a:avLst>
+              <a:gd name="adj" fmla="val 50000"/>
+            </a:avLst>
+          </a:prstGeom>
+          <a:solidFill>
+            <a:schemeClr val="tx2">
+              <a:lumMod val="10000"/>
+              <a:lumOff val="90000"/>
+            </a:schemeClr>
+          </a:solidFill>
+          <a:ln>
+            <a:noFill/>
+          </a:ln>
+        </p:spPr>
+        <p:style>
+          <a:lnRef idx="2">
+            <a:schemeClr val="accent1">
+              <a:shade val="15000"/>
+            </a:schemeClr>
+          </a:lnRef>
+          <a:fillRef idx="1">
+            <a:schemeClr val="accent1"/>
+          </a:fillRef>
+          <a:effectRef idx="0">
+            <a:schemeClr val="accent1"/>
+          </a:effectRef>
+          <a:fontRef idx="minor">
+            <a:schemeClr val="lt1"/>
+          </a:fontRef>
+        </p:style>
+        <p:txBody>
+          <a:bodyPr rtlCol="0" anchor="ctr"/>
+          <a:lstStyle/>
+          <a:p>
+            <a:pPr algn="ctr"/>
+            <a:r>
+              <a:rPr lang="en-US" sz="1600" dirty="0">
+                <a:solidFill>
+                  <a:schemeClr val="bg1"/>
+                </a:solidFill>
+              </a:rPr>
+              <a:t>Fault</a:t>
+            </a:r>
+          </a:p>
+        </p:txBody>
+      </p:sp>
+      <p:sp>
+        <p:nvSpPr>
+          <p:cNvPr id="8" name="Rounded Rectangle 7">
+            <a:extLst>
+              <a:ext uri="{FF2B5EF4-FFF2-40B4-BE49-F238E27FC236}">
+                <a16:creationId xmlns:a16="http://schemas.microsoft.com/office/drawing/2014/main" id="{F3D742E6-2169-9420-27C2-4062F7D49927}"/>
+              </a:ext>
+            </a:extLst>
+          </p:cNvPr>
+          <p:cNvSpPr/>
+          <p:nvPr/>
+        </p:nvSpPr>
+        <p:spPr>
+          <a:xfrm>
+            <a:off x="9441873" y="1757218"/>
+            <a:ext cx="983673" cy="322118"/>
+          </a:xfrm>
+          <a:prstGeom prst="roundRect">
+            <a:avLst>
+              <a:gd name="adj" fmla="val 50000"/>
+            </a:avLst>
+          </a:prstGeom>
+          <a:solidFill>
+            <a:schemeClr val="tx2">
+              <a:lumMod val="10000"/>
+              <a:lumOff val="90000"/>
+            </a:schemeClr>
+          </a:solidFill>
+          <a:ln>
+            <a:noFill/>
+          </a:ln>
+        </p:spPr>
+        <p:style>
+          <a:lnRef idx="2">
+            <a:schemeClr val="accent1">
+              <a:shade val="15000"/>
+            </a:schemeClr>
+          </a:lnRef>
+          <a:fillRef idx="1">
+            <a:schemeClr val="accent1"/>
+          </a:fillRef>
+          <a:effectRef idx="0">
+            <a:schemeClr val="accent1"/>
+          </a:effectRef>
+          <a:fontRef idx="minor">
+            <a:schemeClr val="lt1"/>
+          </a:fontRef>
+        </p:style>
+        <p:txBody>
+          <a:bodyPr rtlCol="0" anchor="ctr"/>
+          <a:lstStyle/>
+          <a:p>
+            <a:pPr algn="ctr"/>
+            <a:r>
+              <a:rPr lang="en-US" sz="1600" dirty="0">
+                <a:solidFill>
+                  <a:schemeClr val="bg1"/>
+                </a:solidFill>
+              </a:rPr>
+              <a:t>xx</a:t>
+            </a:r>
+          </a:p>
+        </p:txBody>
+      </p:sp>
+      <p:pic>
+        <p:nvPicPr>
+          <p:cNvPr id="9" name="Picture 8">
+            <a:extLst>
+              <a:ext uri="{FF2B5EF4-FFF2-40B4-BE49-F238E27FC236}">
+                <a16:creationId xmlns:a16="http://schemas.microsoft.com/office/drawing/2014/main" id="{617B3D4C-CFE5-B012-8752-CAE7840576D6}"/>
+              </a:ext>
+            </a:extLst>
+          </p:cNvPr>
+          <p:cNvPicPr>
+            <a:picLocks noChangeAspect="1"/>
+          </p:cNvPicPr>
+          <p:nvPr/>
+        </p:nvPicPr>
+        <p:blipFill>
+          <a:blip r:embed="rId3"/>
+          <a:stretch>
+            <a:fillRect/>
+          </a:stretch>
+        </p:blipFill>
+        <p:spPr>
+          <a:xfrm>
+            <a:off x="4592782" y="2233190"/>
+            <a:ext cx="5623791" cy="2140228"/>
+          </a:xfrm>
+          <a:prstGeom prst="rect">
+            <a:avLst/>
+          </a:prstGeom>
+        </p:spPr>
+      </p:pic>
+      <p:cxnSp>
+        <p:nvCxnSpPr>
+          <p:cNvPr id="11" name="Straight Connector 10">
+            <a:extLst>
+              <a:ext uri="{FF2B5EF4-FFF2-40B4-BE49-F238E27FC236}">
+                <a16:creationId xmlns:a16="http://schemas.microsoft.com/office/drawing/2014/main" id="{51A8615C-BC2B-1420-726E-B0B3F44E0A01}"/>
+              </a:ext>
+            </a:extLst>
+          </p:cNvPr>
+          <p:cNvCxnSpPr/>
+          <p:nvPr/>
+        </p:nvCxnSpPr>
+        <p:spPr>
+          <a:xfrm>
+            <a:off x="4301836" y="1610591"/>
+            <a:ext cx="0" cy="2587336"/>
+          </a:xfrm>
+          <a:prstGeom prst="line">
+            <a:avLst/>
+          </a:prstGeom>
+          <a:ln>
+            <a:solidFill>
+              <a:schemeClr val="bg2">
+                <a:lumMod val="90000"/>
+              </a:schemeClr>
+            </a:solidFill>
+          </a:ln>
+        </p:spPr>
+        <p:style>
+          <a:lnRef idx="2">
+            <a:schemeClr val="accent1"/>
+          </a:lnRef>
+          <a:fillRef idx="0">
+            <a:schemeClr val="accent1"/>
+          </a:fillRef>
+          <a:effectRef idx="1">
+            <a:schemeClr val="accent1"/>
+          </a:effectRef>
+          <a:fontRef idx="minor">
+            <a:schemeClr val="tx1"/>
+          </a:fontRef>
+        </p:style>
+      </p:cxnSp>
+    </p:spTree>
+    <p:extLst>
+      <p:ext uri="{BB962C8B-B14F-4D97-AF65-F5344CB8AC3E}">
+        <p14:creationId xmlns:p14="http://schemas.microsoft.com/office/powerpoint/2010/main" val="2544364639"/>
+      </p:ext>
+    </p:extLst>
+  </p:cSld>
+  <p:clrMapOvr>
+    <a:masterClrMapping/>
+  </p:clrMapOvr>
+</p:sld>
+</file>
+
+<file path=ppt/slides/slide3.xml><?xml version="1.0" encoding="utf-8"?>
+<p:sld xmlns:a="http://schemas.openxmlformats.org/drawingml/2006/main" xmlns:r="http://schemas.openxmlformats.org/officeDocument/2006/relationships" xmlns:p="http://schemas.openxmlformats.org/presentationml/2006/main">
+  <p:cSld>
+    <p:spTree>
+      <p:nvGrpSpPr>
+        <p:cNvPr id="1" name="">
+          <a:extLst>
+            <a:ext uri="{FF2B5EF4-FFF2-40B4-BE49-F238E27FC236}">
+              <a16:creationId xmlns:a16="http://schemas.microsoft.com/office/drawing/2014/main" id="{B5B51167-649F-1F6E-FD0D-716205EE300F}"/>
+            </a:ext>
+          </a:extLst>
+        </p:cNvPr>
+        <p:cNvGrpSpPr/>
+        <p:nvPr/>
+      </p:nvGrpSpPr>
+      <p:grpSpPr>
+        <a:xfrm>
+          <a:off x="0" y="0"/>
+          <a:ext cx="0" cy="0"/>
+          <a:chOff x="0" y="0"/>
+          <a:chExt cx="0" cy="0"/>
+        </a:xfrm>
+      </p:grpSpPr>
+      <p:pic>
+        <p:nvPicPr>
+          <p:cNvPr id="4" name="Picture 3">
+            <a:extLst>
+              <a:ext uri="{FF2B5EF4-FFF2-40B4-BE49-F238E27FC236}">
+                <a16:creationId xmlns:a16="http://schemas.microsoft.com/office/drawing/2014/main" id="{FACD900C-67F6-DEFF-B8A5-52503C695EBD}"/>
+              </a:ext>
+            </a:extLst>
+          </p:cNvPr>
+          <p:cNvPicPr>
+            <a:picLocks noChangeAspect="1"/>
+          </p:cNvPicPr>
+          <p:nvPr/>
+        </p:nvPicPr>
+        <p:blipFill>
+          <a:blip r:embed="rId2"/>
+          <a:stretch>
+            <a:fillRect/>
+          </a:stretch>
+        </p:blipFill>
+        <p:spPr>
+          <a:xfrm>
+            <a:off x="757959" y="1757218"/>
+            <a:ext cx="3340100" cy="2616200"/>
+          </a:xfrm>
+          <a:prstGeom prst="rect">
+            <a:avLst/>
+          </a:prstGeom>
+        </p:spPr>
+      </p:pic>
+      <p:sp>
+        <p:nvSpPr>
+          <p:cNvPr id="5" name="Rounded Rectangle 4">
+            <a:extLst>
+              <a:ext uri="{FF2B5EF4-FFF2-40B4-BE49-F238E27FC236}">
+                <a16:creationId xmlns:a16="http://schemas.microsoft.com/office/drawing/2014/main" id="{93D43386-1389-7F8A-7336-79745162492F}"/>
+              </a:ext>
+            </a:extLst>
+          </p:cNvPr>
+          <p:cNvSpPr/>
+          <p:nvPr/>
+        </p:nvSpPr>
+        <p:spPr>
+          <a:xfrm>
+            <a:off x="4592782" y="1757218"/>
+            <a:ext cx="1735282" cy="322118"/>
+          </a:xfrm>
+          <a:prstGeom prst="roundRect">
+            <a:avLst>
+              <a:gd name="adj" fmla="val 50000"/>
+            </a:avLst>
+          </a:prstGeom>
+          <a:solidFill>
+            <a:schemeClr val="tx1"/>
+          </a:solidFill>
+          <a:ln>
+            <a:noFill/>
+          </a:ln>
+        </p:spPr>
+        <p:style>
+          <a:lnRef idx="2">
+            <a:schemeClr val="accent1">
+              <a:shade val="15000"/>
+            </a:schemeClr>
+          </a:lnRef>
+          <a:fillRef idx="1">
+            <a:schemeClr val="accent1"/>
+          </a:fillRef>
+          <a:effectRef idx="0">
+            <a:schemeClr val="accent1"/>
+          </a:effectRef>
+          <a:fontRef idx="minor">
+            <a:schemeClr val="lt1"/>
+          </a:fontRef>
+        </p:style>
+        <p:txBody>
+          <a:bodyPr rtlCol="0" anchor="ctr"/>
+          <a:lstStyle/>
+          <a:p>
+            <a:pPr algn="ctr"/>
+            <a:r>
+              <a:rPr lang="en-US" sz="1600" dirty="0"/>
+              <a:t>PV technology</a:t>
+            </a:r>
+          </a:p>
+        </p:txBody>
+      </p:sp>
+      <p:sp>
+        <p:nvSpPr>
+          <p:cNvPr id="6" name="Rounded Rectangle 5">
+            <a:extLst>
+              <a:ext uri="{FF2B5EF4-FFF2-40B4-BE49-F238E27FC236}">
+                <a16:creationId xmlns:a16="http://schemas.microsoft.com/office/drawing/2014/main" id="{EFAC042C-1946-0373-E39A-2067378C8331}"/>
+              </a:ext>
+            </a:extLst>
+          </p:cNvPr>
+          <p:cNvSpPr/>
+          <p:nvPr/>
+        </p:nvSpPr>
+        <p:spPr>
+          <a:xfrm>
+            <a:off x="6459682" y="1757218"/>
+            <a:ext cx="1735282" cy="322118"/>
+          </a:xfrm>
+          <a:prstGeom prst="roundRect">
+            <a:avLst>
+              <a:gd name="adj" fmla="val 50000"/>
+            </a:avLst>
+          </a:prstGeom>
+          <a:solidFill>
+            <a:schemeClr val="tx2">
+              <a:lumMod val="10000"/>
+              <a:lumOff val="90000"/>
+            </a:schemeClr>
+          </a:solidFill>
+          <a:ln>
+            <a:noFill/>
+          </a:ln>
+        </p:spPr>
+        <p:style>
+          <a:lnRef idx="2">
+            <a:schemeClr val="accent1">
+              <a:shade val="15000"/>
+            </a:schemeClr>
+          </a:lnRef>
+          <a:fillRef idx="1">
+            <a:schemeClr val="accent1"/>
+          </a:fillRef>
+          <a:effectRef idx="0">
+            <a:schemeClr val="accent1"/>
+          </a:effectRef>
+          <a:fontRef idx="minor">
+            <a:schemeClr val="lt1"/>
+          </a:fontRef>
+        </p:style>
+        <p:txBody>
+          <a:bodyPr rtlCol="0" anchor="ctr"/>
+          <a:lstStyle/>
+          <a:p>
+            <a:pPr algn="ctr"/>
+            <a:r>
+              <a:rPr lang="en-US" sz="1600" dirty="0">
+                <a:solidFill>
+                  <a:schemeClr val="bg1"/>
+                </a:solidFill>
+              </a:rPr>
+              <a:t>Study duration</a:t>
+            </a:r>
+          </a:p>
+        </p:txBody>
+      </p:sp>
+      <p:sp>
+        <p:nvSpPr>
+          <p:cNvPr id="7" name="Rounded Rectangle 6">
+            <a:extLst>
+              <a:ext uri="{FF2B5EF4-FFF2-40B4-BE49-F238E27FC236}">
+                <a16:creationId xmlns:a16="http://schemas.microsoft.com/office/drawing/2014/main" id="{EDDBA585-5545-5CCE-3B48-EB57ADCDEF88}"/>
+              </a:ext>
+            </a:extLst>
+          </p:cNvPr>
+          <p:cNvSpPr/>
+          <p:nvPr/>
+        </p:nvSpPr>
+        <p:spPr>
+          <a:xfrm>
+            <a:off x="8326582" y="1757218"/>
+            <a:ext cx="983673" cy="322118"/>
+          </a:xfrm>
+          <a:prstGeom prst="roundRect">
+            <a:avLst>
+              <a:gd name="adj" fmla="val 50000"/>
+            </a:avLst>
+          </a:prstGeom>
+          <a:solidFill>
+            <a:schemeClr val="tx2">
+              <a:lumMod val="10000"/>
+              <a:lumOff val="90000"/>
+            </a:schemeClr>
+          </a:solidFill>
+          <a:ln>
+            <a:noFill/>
+          </a:ln>
+        </p:spPr>
+        <p:style>
+          <a:lnRef idx="2">
+            <a:schemeClr val="accent1">
+              <a:shade val="15000"/>
+            </a:schemeClr>
+          </a:lnRef>
+          <a:fillRef idx="1">
+            <a:schemeClr val="accent1"/>
+          </a:fillRef>
+          <a:effectRef idx="0">
+            <a:schemeClr val="accent1"/>
+          </a:effectRef>
+          <a:fontRef idx="minor">
+            <a:schemeClr val="lt1"/>
+          </a:fontRef>
+        </p:style>
+        <p:txBody>
+          <a:bodyPr rtlCol="0" anchor="ctr"/>
+          <a:lstStyle/>
+          <a:p>
+            <a:pPr algn="ctr"/>
+            <a:r>
+              <a:rPr lang="en-US" sz="1600" dirty="0">
+                <a:solidFill>
+                  <a:schemeClr val="bg1"/>
+                </a:solidFill>
+              </a:rPr>
+              <a:t>Fault</a:t>
+            </a:r>
+          </a:p>
+        </p:txBody>
+      </p:sp>
+      <p:sp>
+        <p:nvSpPr>
+          <p:cNvPr id="8" name="Rounded Rectangle 7">
+            <a:extLst>
+              <a:ext uri="{FF2B5EF4-FFF2-40B4-BE49-F238E27FC236}">
+                <a16:creationId xmlns:a16="http://schemas.microsoft.com/office/drawing/2014/main" id="{8AFAC618-F632-1C5E-0CB4-267A9642BCC4}"/>
+              </a:ext>
+            </a:extLst>
+          </p:cNvPr>
+          <p:cNvSpPr/>
+          <p:nvPr/>
+        </p:nvSpPr>
+        <p:spPr>
+          <a:xfrm>
+            <a:off x="9441873" y="1757218"/>
+            <a:ext cx="983673" cy="322118"/>
+          </a:xfrm>
+          <a:prstGeom prst="roundRect">
+            <a:avLst>
+              <a:gd name="adj" fmla="val 50000"/>
+            </a:avLst>
+          </a:prstGeom>
+          <a:solidFill>
+            <a:schemeClr val="tx2">
+              <a:lumMod val="10000"/>
+              <a:lumOff val="90000"/>
+            </a:schemeClr>
+          </a:solidFill>
+          <a:ln>
+            <a:noFill/>
+          </a:ln>
+        </p:spPr>
+        <p:style>
+          <a:lnRef idx="2">
+            <a:schemeClr val="accent1">
+              <a:shade val="15000"/>
+            </a:schemeClr>
+          </a:lnRef>
+          <a:fillRef idx="1">
+            <a:schemeClr val="accent1"/>
+          </a:fillRef>
+          <a:effectRef idx="0">
+            <a:schemeClr val="accent1"/>
+          </a:effectRef>
+          <a:fontRef idx="minor">
+            <a:schemeClr val="lt1"/>
+          </a:fontRef>
+        </p:style>
+        <p:txBody>
+          <a:bodyPr rtlCol="0" anchor="ctr"/>
+          <a:lstStyle/>
+          <a:p>
+            <a:pPr algn="ctr"/>
+            <a:r>
+              <a:rPr lang="en-US" sz="1600" dirty="0">
+                <a:solidFill>
+                  <a:schemeClr val="bg1"/>
+                </a:solidFill>
+              </a:rPr>
+              <a:t>xx</a:t>
+            </a:r>
+          </a:p>
+        </p:txBody>
+      </p:sp>
+      <p:pic>
+        <p:nvPicPr>
+          <p:cNvPr id="9" name="Picture 8">
+            <a:extLst>
+              <a:ext uri="{FF2B5EF4-FFF2-40B4-BE49-F238E27FC236}">
+                <a16:creationId xmlns:a16="http://schemas.microsoft.com/office/drawing/2014/main" id="{6A856BD2-C8C2-966E-1E7F-83F3D7298037}"/>
+              </a:ext>
+            </a:extLst>
+          </p:cNvPr>
+          <p:cNvPicPr>
+            <a:picLocks noChangeAspect="1"/>
+          </p:cNvPicPr>
+          <p:nvPr/>
+        </p:nvPicPr>
+        <p:blipFill>
+          <a:blip r:embed="rId3"/>
+          <a:stretch>
+            <a:fillRect/>
+          </a:stretch>
+        </p:blipFill>
+        <p:spPr>
+          <a:xfrm>
+            <a:off x="4592782" y="2233190"/>
+            <a:ext cx="5623791" cy="2140228"/>
+          </a:xfrm>
+          <a:prstGeom prst="rect">
+            <a:avLst/>
+          </a:prstGeom>
+        </p:spPr>
+      </p:pic>
+      <p:cxnSp>
+        <p:nvCxnSpPr>
+          <p:cNvPr id="11" name="Straight Connector 10">
+            <a:extLst>
+              <a:ext uri="{FF2B5EF4-FFF2-40B4-BE49-F238E27FC236}">
+                <a16:creationId xmlns:a16="http://schemas.microsoft.com/office/drawing/2014/main" id="{87C1ACA9-B382-0787-BEE9-82694A141E87}"/>
+              </a:ext>
+            </a:extLst>
+          </p:cNvPr>
+          <p:cNvCxnSpPr/>
+          <p:nvPr/>
+        </p:nvCxnSpPr>
+        <p:spPr>
+          <a:xfrm>
+            <a:off x="4301836" y="1610591"/>
+            <a:ext cx="0" cy="2587336"/>
+          </a:xfrm>
+          <a:prstGeom prst="line">
+            <a:avLst/>
+          </a:prstGeom>
+          <a:ln>
+            <a:solidFill>
+              <a:schemeClr val="bg2">
+                <a:lumMod val="90000"/>
+              </a:schemeClr>
+            </a:solidFill>
+          </a:ln>
+        </p:spPr>
+        <p:style>
+          <a:lnRef idx="2">
+            <a:schemeClr val="accent1"/>
+          </a:lnRef>
+          <a:fillRef idx="0">
+            <a:schemeClr val="accent1"/>
+          </a:fillRef>
+          <a:effectRef idx="1">
+            <a:schemeClr val="accent1"/>
+          </a:effectRef>
+          <a:fontRef idx="minor">
+            <a:schemeClr val="tx1"/>
+          </a:fontRef>
+        </p:style>
+      </p:cxnSp>
+    </p:spTree>
+    <p:extLst>
+      <p:ext uri="{BB962C8B-B14F-4D97-AF65-F5344CB8AC3E}">
+        <p14:creationId xmlns:p14="http://schemas.microsoft.com/office/powerpoint/2010/main" val="3064646569"/>
       </p:ext>
     </p:extLst>
   </p:cSld>

</xml_diff>